<commit_message>
Audit fixes: reconcile report/slides, fix web-demo deps, repo hygiene
- app/: pin gradio==4.44.0, numpy<2, matplotlib<3.10, tf==2.15; replace removed
  matplotlib cm.get_cmap with colormaps[] (would crash a fresh HF Spaces build)
- notebook/: same get_cmap fix + regenerate .ipynb; cap run_on_kaggle.sh poll loop
- report: fix results-table sizes to satisfy the params x4 equation (16.0/28.4/114.4 MB),
  resizebox the overfull table, align efficiency prose, cite 2 previously-unused refs
- slides: reconcile all size/latency/Top-3 numbers with the report and flip slide-11
  narrative to match (Custom CNN smallest-but-slowest); add Params column; placeholder notes
- video script: add required ~2 min live-demo segment, retarget to ~10 min
- README: fix repo name, add figures unzip-path guidance; remove Vercel mention in docx
- add LICENSE (MIT); ignore kaggle.json/.kaggle/ to prevent token leaks

Co-Authored-By: Claude Opus 4.8 (1M context) <noreply@anthropic.com>
</commit_message>
<xml_diff>
--- a/slides/sports_cnn_presentation.pptx
+++ b/slides/sports_cnn_presentation.pptx
@@ -583,7 +583,7 @@
           <a:lstStyle/>
           <a:p>
             <a:r>
-              <a:t>Show Grad-CAM and SHAP agree on correct cases and expose background reliance on wrong ones. ~45s.</a:t>
+              <a:t>Show Grad-CAM and SHAP agree on correct cases and expose background reliance on wrong ones. ~45s. ⚠ Replace the two figure placeholders with gradcam.png and shap.png from results.zip before recording.</a:t>
             </a:r>
           </a:p>
         </p:txBody>
@@ -653,7 +653,7 @@
           <a:lstStyle/>
           <a:p>
             <a:r>
-              <a:t>Argue for balance over raw accuracy; introduce the live demo (you will show it in the 2-min demo part). ~40s.</a:t>
+              <a:t>Argue for balance over raw accuracy; introduce the live demo (you will show it in the 2-min demo part). ~40s. ⚠ Size/latency numbers are placeholders — replace with real Kaggle results before recording.</a:t>
             </a:r>
           </a:p>
         </p:txBody>
@@ -723,7 +723,7 @@
           <a:lstStyle/>
           <a:p>
             <a:r>
-              <a:t>Summarise the four takeaways, state limitations honestly, and thank the audience. ~40s.</a:t>
+              <a:t>Summarise the four takeaways, state limitations honestly, and thank the audience. ~40s. ⚠ The ~91% headline is a placeholder — replace with your real best-model accuracy before recording.</a:t>
             </a:r>
           </a:p>
         </p:txBody>
@@ -863,7 +863,7 @@
           <a:lstStyle/>
           <a:p>
             <a:r>
-              <a:t>Describe the dataset and preprocessing. Point to the sample grid and the near-balanced distribution. ~40s.</a:t>
+              <a:t>Describe the dataset and preprocessing. Point to the sample grid and the near-balanced distribution. ~40s. ⚠ Replace the two figure placeholders with sample_grid.png and class_distribution.png from results.zip before recording.</a:t>
             </a:r>
           </a:p>
         </p:txBody>
@@ -1143,7 +1143,7 @@
           <a:lstStyle/>
           <a:p>
             <a:r>
-              <a:t>Read the training curves: convergence, early stopping, and the train-val gap as an overfitting check. ~35s.</a:t>
+              <a:t>Read the training curves: convergence, early stopping, and the train-val gap as an overfitting check. ~35s. ⚠ Replace the figure placeholder with training_curves.png from results.zip before recording.</a:t>
             </a:r>
           </a:p>
         </p:txBody>
@@ -1283,7 +1283,7 @@
           <a:lstStyle/>
           <a:p>
             <a:r>
-              <a:t>Use the confusion matrix to name the hardest, most-confused sports and the easiest ones. ~35s.</a:t>
+              <a:t>Use the confusion matrix to name the hardest, most-confused sports and the easiest ones. ~35s. ⚠ Replace the figure placeholder with confusion_matrix.png from results.zip before recording.</a:t>
             </a:r>
           </a:p>
         </p:txBody>
@@ -5708,7 +5708,7 @@
                 </a:solidFill>
                 <a:latin typeface="Calibri"/>
               </a:rPr>
-              <a:t>4.9 MB · 3.4 ms.</a:t>
+              <a:t>16 MB · 31.5 ms.</a:t>
             </a:r>
           </a:p>
           <a:p>
@@ -5727,7 +5727,7 @@
                 </a:solidFill>
                 <a:latin typeface="Calibri"/>
               </a:rPr>
-              <a:t>Smallest and fastest; best where compute is tight.</a:t>
+              <a:t>Fewest parameters and smallest file — yet, counter-intuitively, the slowest at inference (architecture matters more than param count).</a:t>
             </a:r>
           </a:p>
         </p:txBody>
@@ -5834,7 +5834,7 @@
                 </a:solidFill>
                 <a:latin typeface="Calibri"/>
               </a:rPr>
-              <a:t>38 MB · 4.8 ms.</a:t>
+              <a:t>28 MB · 20.4 ms.</a:t>
             </a:r>
           </a:p>
           <a:p>
@@ -5853,7 +5853,7 @@
                 </a:solidFill>
                 <a:latin typeface="Calibri"/>
               </a:rPr>
-              <a:t>Top accuracy, compact, fast.</a:t>
+              <a:t>Highest accuracy AND lowest latency.</a:t>
             </a:r>
           </a:p>
           <a:p>
@@ -5979,7 +5979,7 @@
                 </a:solidFill>
                 <a:latin typeface="Calibri"/>
               </a:rPr>
-              <a:t>235 MB · 12.9 ms.</a:t>
+              <a:t>114 MB · 23.2 ms.</a:t>
             </a:r>
           </a:p>
           <a:p>
@@ -5998,7 +5998,7 @@
                 </a:solidFill>
                 <a:latin typeface="Calibri"/>
               </a:rPr>
-              <a:t>Highest capacity, but ~6x larger and slower for marginal gains.</a:t>
+              <a:t>Highest capacity and largest footprint, for slightly lower accuracy.</a:t>
             </a:r>
           </a:p>
         </p:txBody>
@@ -9853,7 +9853,7 @@
                 </a:solidFill>
                 <a:latin typeface="Calibri"/>
               </a:rPr>
-              <a:t>Lightweight baseline.</a:t>
+              <a:t>~4.0M parameters; lightweight baseline.</a:t>
             </a:r>
           </a:p>
         </p:txBody>
@@ -9998,7 +9998,7 @@
                 </a:solidFill>
                 <a:latin typeface="Calibri"/>
               </a:rPr>
-              <a:t>Two-phase fine-tuning; ~6-7M parameters.</a:t>
+              <a:t>Two-phase fine-tuning; ~7.1M parameters.</a:t>
             </a:r>
           </a:p>
           <a:p>
@@ -10162,7 +10162,7 @@
                 </a:solidFill>
                 <a:latin typeface="Calibri"/>
               </a:rPr>
-              <a:t>Two-phase fine-tuning; ~28M parameters.</a:t>
+              <a:t>Two-phase fine-tuning; ~28.6M parameters.</a:t>
             </a:r>
           </a:p>
           <a:p>
@@ -10991,7 +10991,7 @@
         </p:nvGraphicFramePr>
         <p:xfrm>
           <a:off x="640080" y="1828800"/>
-          <a:ext cx="10908791" cy="2240280"/>
+          <a:ext cx="10908790" cy="2240280"/>
         </p:xfrm>
         <a:graphic>
           <a:graphicData uri="http://schemas.openxmlformats.org/drawingml/2006/table">
@@ -11000,12 +11000,13 @@
                 <a:tableStyleId>{5C22544A-7EE6-4342-B048-85BDC9FD1C3A}</a:tableStyleId>
               </a:tblPr>
               <a:tblGrid>
-                <a:gridCol w="3108960"/>
-                <a:gridCol w="1600199"/>
-                <a:gridCol w="1508760"/>
-                <a:gridCol w="1325880"/>
-                <a:gridCol w="1627632"/>
-                <a:gridCol w="1737360"/>
+                <a:gridCol w="2669662"/>
+                <a:gridCol w="1426888"/>
+                <a:gridCol w="1426888"/>
+                <a:gridCol w="1196745"/>
+                <a:gridCol w="1334831"/>
+                <a:gridCol w="1334831"/>
+                <a:gridCol w="1518945"/>
               </a:tblGrid>
               <a:tr h="560070">
                 <a:tc>
@@ -11113,7 +11114,7 @@
                           </a:solidFill>
                           <a:latin typeface="Calibri"/>
                         </a:rPr>
-                        <a:t>Inference</a:t>
+                        <a:t>Params</a:t>
                       </a:r>
                     </a:p>
                   </a:txBody>
@@ -11137,6 +11138,29 @@
                           <a:latin typeface="Calibri"/>
                         </a:rPr>
                         <a:t>Size</a:t>
+                      </a:r>
+                    </a:p>
+                  </a:txBody>
+                  <a:tcPr anchor="ctr">
+                    <a:solidFill>
+                      <a:srgbClr val="213952"/>
+                    </a:solidFill>
+                  </a:tcPr>
+                </a:tc>
+                <a:tc>
+                  <a:txBody>
+                    <a:bodyPr/>
+                    <a:lstStyle/>
+                    <a:p>
+                      <a:pPr algn="ctr"/>
+                      <a:r>
+                        <a:rPr sz="1400" b="1" i="0">
+                          <a:solidFill>
+                            <a:srgbClr val="FFFFFF"/>
+                          </a:solidFill>
+                          <a:latin typeface="Calibri"/>
+                        </a:rPr>
+                        <a:t>Inference</a:t>
                       </a:r>
                     </a:p>
                   </a:txBody>
@@ -11230,7 +11254,7 @@
                           </a:solidFill>
                           <a:latin typeface="Calibri"/>
                         </a:rPr>
-                        <a:t>0.921</a:t>
+                        <a:t>0.928</a:t>
                       </a:r>
                     </a:p>
                   </a:txBody>
@@ -11253,7 +11277,7 @@
                           </a:solidFill>
                           <a:latin typeface="Calibri"/>
                         </a:rPr>
-                        <a:t>3.4 ms</a:t>
+                        <a:t>4.0 M</a:t>
                       </a:r>
                     </a:p>
                   </a:txBody>
@@ -11276,7 +11300,30 @@
                           </a:solidFill>
                           <a:latin typeface="Calibri"/>
                         </a:rPr>
-                        <a:t>4.9 MB</a:t>
+                        <a:t>16 MB</a:t>
+                      </a:r>
+                    </a:p>
+                  </a:txBody>
+                  <a:tcPr anchor="ctr">
+                    <a:solidFill>
+                      <a:srgbClr val="FFFFFF"/>
+                    </a:solidFill>
+                  </a:tcPr>
+                </a:tc>
+                <a:tc>
+                  <a:txBody>
+                    <a:bodyPr/>
+                    <a:lstStyle/>
+                    <a:p>
+                      <a:pPr algn="ctr"/>
+                      <a:r>
+                        <a:rPr sz="1350" b="0" i="0">
+                          <a:solidFill>
+                            <a:srgbClr val="1F2A37"/>
+                          </a:solidFill>
+                          <a:latin typeface="Calibri"/>
+                        </a:rPr>
+                        <a:t>31.5 ms</a:t>
                       </a:r>
                     </a:p>
                   </a:txBody>
@@ -11370,7 +11417,7 @@
                           </a:solidFill>
                           <a:latin typeface="Calibri"/>
                         </a:rPr>
-                        <a:t>0.974</a:t>
+                        <a:t>0.976</a:t>
                       </a:r>
                     </a:p>
                   </a:txBody>
@@ -11393,7 +11440,7 @@
                           </a:solidFill>
                           <a:latin typeface="Calibri"/>
                         </a:rPr>
-                        <a:t>4.8 ms</a:t>
+                        <a:t>7.1 M</a:t>
                       </a:r>
                     </a:p>
                   </a:txBody>
@@ -11416,7 +11463,30 @@
                           </a:solidFill>
                           <a:latin typeface="Calibri"/>
                         </a:rPr>
-                        <a:t>38 MB</a:t>
+                        <a:t>28 MB</a:t>
+                      </a:r>
+                    </a:p>
+                  </a:txBody>
+                  <a:tcPr anchor="ctr">
+                    <a:solidFill>
+                      <a:srgbClr val="EEF4FB"/>
+                    </a:solidFill>
+                  </a:tcPr>
+                </a:tc>
+                <a:tc>
+                  <a:txBody>
+                    <a:bodyPr/>
+                    <a:lstStyle/>
+                    <a:p>
+                      <a:pPr algn="ctr"/>
+                      <a:r>
+                        <a:rPr sz="1350" b="0" i="0">
+                          <a:solidFill>
+                            <a:srgbClr val="213952"/>
+                          </a:solidFill>
+                          <a:latin typeface="Calibri"/>
+                        </a:rPr>
+                        <a:t>20.4 ms</a:t>
                       </a:r>
                     </a:p>
                   </a:txBody>
@@ -11510,7 +11580,7 @@
                           </a:solidFill>
                           <a:latin typeface="Calibri"/>
                         </a:rPr>
-                        <a:t>0.962</a:t>
+                        <a:t>0.965</a:t>
                       </a:r>
                     </a:p>
                   </a:txBody>
@@ -11533,7 +11603,7 @@
                           </a:solidFill>
                           <a:latin typeface="Calibri"/>
                         </a:rPr>
-                        <a:t>12.9 ms</a:t>
+                        <a:t>28.6 M</a:t>
                       </a:r>
                     </a:p>
                   </a:txBody>
@@ -11556,7 +11626,30 @@
                           </a:solidFill>
                           <a:latin typeface="Calibri"/>
                         </a:rPr>
-                        <a:t>235 MB</a:t>
+                        <a:t>114 MB</a:t>
+                      </a:r>
+                    </a:p>
+                  </a:txBody>
+                  <a:tcPr anchor="ctr">
+                    <a:solidFill>
+                      <a:srgbClr val="FFFFFF"/>
+                    </a:solidFill>
+                  </a:tcPr>
+                </a:tc>
+                <a:tc>
+                  <a:txBody>
+                    <a:bodyPr/>
+                    <a:lstStyle/>
+                    <a:p>
+                      <a:pPr algn="ctr"/>
+                      <a:r>
+                        <a:rPr sz="1350" b="0" i="0">
+                          <a:solidFill>
+                            <a:srgbClr val="1F2A37"/>
+                          </a:solidFill>
+                          <a:latin typeface="Calibri"/>
+                        </a:rPr>
+                        <a:t>23.2 ms</a:t>
                       </a:r>
                     </a:p>
                   </a:txBody>
@@ -11780,7 +11873,7 @@
                 </a:solidFill>
                 <a:latin typeface="Calibri"/>
               </a:rPr>
-              <a:t>EfficientNetV2-B0 matches the top accuracy at a fraction of ConvNeXt-Tiny's size and latency — the best balance for deployment (RQ4).</a:t>
+              <a:t>EfficientNetV2-B0 delivers the highest accuracy AND the lowest latency at about a quarter of ConvNeXt-Tiny's size — the best balance for deployment (RQ4).</a:t>
             </a:r>
           </a:p>
         </p:txBody>

</xml_diff>